<commit_message>
Sincronizo para subir nuevas notas
</commit_message>
<xml_diff>
--- a/Reporte 250926.pptx
+++ b/Reporte 250926.pptx
@@ -6591,10 +6591,10 @@
       </p:sp>
       <p:pic>
         <p:nvPicPr>
-          <p:cNvPr id="4" name="Imagen 3">
+          <p:cNvPr id="5" name="Imagen 4">
             <a:extLst>
               <a:ext uri="{FF2B5EF4-FFF2-40B4-BE49-F238E27FC236}">
-                <a16:creationId xmlns:a16="http://schemas.microsoft.com/office/drawing/2014/main" id="{552C8CBD-6527-FF11-9A19-39864D354CBA}"/>
+                <a16:creationId xmlns:a16="http://schemas.microsoft.com/office/drawing/2014/main" id="{8091EC6E-315B-B95F-E2AE-37075A65B65E}"/>
               </a:ext>
             </a:extLst>
           </p:cNvPr>
@@ -6611,8 +6611,8 @@
         </p:blipFill>
         <p:spPr>
           <a:xfrm>
-            <a:off x="0" y="734587"/>
-            <a:ext cx="9144000" cy="3817201"/>
+            <a:off x="-6725" y="739036"/>
+            <a:ext cx="9144000" cy="3808303"/>
           </a:xfrm>
           <a:prstGeom prst="rect">
             <a:avLst/>
@@ -6697,10 +6697,10 @@
       </p:sp>
       <p:pic>
         <p:nvPicPr>
-          <p:cNvPr id="4" name="Imagen 3">
+          <p:cNvPr id="3" name="Imagen 2">
             <a:extLst>
               <a:ext uri="{FF2B5EF4-FFF2-40B4-BE49-F238E27FC236}">
-                <a16:creationId xmlns:a16="http://schemas.microsoft.com/office/drawing/2014/main" id="{1119109F-B64C-2C8A-5B2F-9123081F02B6}"/>
+                <a16:creationId xmlns:a16="http://schemas.microsoft.com/office/drawing/2014/main" id="{433F7A71-8E00-2197-C724-AB547A85D63A}"/>
               </a:ext>
             </a:extLst>
           </p:cNvPr>
@@ -6717,8 +6717,8 @@
         </p:blipFill>
         <p:spPr>
           <a:xfrm>
-            <a:off x="0" y="1163411"/>
-            <a:ext cx="9144000" cy="2959554"/>
+            <a:off x="0" y="1103897"/>
+            <a:ext cx="9144000" cy="3078582"/>
           </a:xfrm>
           <a:prstGeom prst="rect">
             <a:avLst/>
@@ -6803,10 +6803,10 @@
       </p:sp>
       <p:pic>
         <p:nvPicPr>
-          <p:cNvPr id="4" name="Imagen 3">
+          <p:cNvPr id="5" name="Imagen 4">
             <a:extLst>
               <a:ext uri="{FF2B5EF4-FFF2-40B4-BE49-F238E27FC236}">
-                <a16:creationId xmlns:a16="http://schemas.microsoft.com/office/drawing/2014/main" id="{67DA0C24-F1D0-7195-2439-206AF7887901}"/>
+                <a16:creationId xmlns:a16="http://schemas.microsoft.com/office/drawing/2014/main" id="{C127A404-7CB1-C3A9-F35D-7DE66BB30109}"/>
               </a:ext>
             </a:extLst>
           </p:cNvPr>
@@ -6823,8 +6823,8 @@
         </p:blipFill>
         <p:spPr>
           <a:xfrm>
-            <a:off x="0" y="568358"/>
-            <a:ext cx="9144000" cy="4149660"/>
+            <a:off x="0" y="581039"/>
+            <a:ext cx="9144000" cy="4124297"/>
           </a:xfrm>
           <a:prstGeom prst="rect">
             <a:avLst/>
@@ -6909,10 +6909,10 @@
       </p:sp>
       <p:pic>
         <p:nvPicPr>
-          <p:cNvPr id="4" name="Imagen 3">
+          <p:cNvPr id="3" name="Imagen 2">
             <a:extLst>
               <a:ext uri="{FF2B5EF4-FFF2-40B4-BE49-F238E27FC236}">
-                <a16:creationId xmlns:a16="http://schemas.microsoft.com/office/drawing/2014/main" id="{1596AAD3-9BDC-393F-A629-C73FF5872C90}"/>
+                <a16:creationId xmlns:a16="http://schemas.microsoft.com/office/drawing/2014/main" id="{1CB702B5-7F94-0583-6EE4-BB42B189F174}"/>
               </a:ext>
             </a:extLst>
           </p:cNvPr>
@@ -6929,8 +6929,8 @@
         </p:blipFill>
         <p:spPr>
           <a:xfrm>
-            <a:off x="0" y="1154807"/>
-            <a:ext cx="9144000" cy="2976761"/>
+            <a:off x="0" y="1200732"/>
+            <a:ext cx="9144000" cy="2986836"/>
           </a:xfrm>
           <a:prstGeom prst="rect">
             <a:avLst/>
@@ -7015,10 +7015,10 @@
       </p:sp>
       <p:pic>
         <p:nvPicPr>
-          <p:cNvPr id="4" name="Imagen 3">
+          <p:cNvPr id="3" name="Imagen 2">
             <a:extLst>
               <a:ext uri="{FF2B5EF4-FFF2-40B4-BE49-F238E27FC236}">
-                <a16:creationId xmlns:a16="http://schemas.microsoft.com/office/drawing/2014/main" id="{009E711B-CF25-098D-A05D-EEC589CB6152}"/>
+                <a16:creationId xmlns:a16="http://schemas.microsoft.com/office/drawing/2014/main" id="{56DCE994-E020-A181-FD22-3CCDB7A2C0C9}"/>
               </a:ext>
             </a:extLst>
           </p:cNvPr>
@@ -7035,8 +7035,8 @@
         </p:blipFill>
         <p:spPr>
           <a:xfrm>
-            <a:off x="0" y="451693"/>
-            <a:ext cx="9144000" cy="4382990"/>
+            <a:off x="0" y="473468"/>
+            <a:ext cx="9144000" cy="4339439"/>
           </a:xfrm>
           <a:prstGeom prst="rect">
             <a:avLst/>
@@ -7127,10 +7127,10 @@
       </p:sp>
       <p:pic>
         <p:nvPicPr>
-          <p:cNvPr id="4" name="Imagen 3">
+          <p:cNvPr id="3" name="Imagen 2">
             <a:extLst>
               <a:ext uri="{FF2B5EF4-FFF2-40B4-BE49-F238E27FC236}">
-                <a16:creationId xmlns:a16="http://schemas.microsoft.com/office/drawing/2014/main" id="{82F3E00F-4662-7B61-5688-31A4A13040EC}"/>
+                <a16:creationId xmlns:a16="http://schemas.microsoft.com/office/drawing/2014/main" id="{5D104F9A-D558-8AA2-F3EE-BF61BFEDE582}"/>
               </a:ext>
             </a:extLst>
           </p:cNvPr>
@@ -7147,8 +7147,8 @@
         </p:blipFill>
         <p:spPr>
           <a:xfrm>
-            <a:off x="-36512" y="684484"/>
-            <a:ext cx="9144000" cy="3917407"/>
+            <a:off x="-36512" y="690669"/>
+            <a:ext cx="9144000" cy="3905038"/>
           </a:xfrm>
           <a:prstGeom prst="rect">
             <a:avLst/>
@@ -7239,10 +7239,10 @@
       </p:sp>
       <p:pic>
         <p:nvPicPr>
-          <p:cNvPr id="3" name="Imagen 2">
+          <p:cNvPr id="4" name="Imagen 3">
             <a:extLst>
               <a:ext uri="{FF2B5EF4-FFF2-40B4-BE49-F238E27FC236}">
-                <a16:creationId xmlns:a16="http://schemas.microsoft.com/office/drawing/2014/main" id="{309F009F-A13E-584A-D8E0-A5930D8EC354}"/>
+                <a16:creationId xmlns:a16="http://schemas.microsoft.com/office/drawing/2014/main" id="{36740A1D-6AF0-82B0-F6DB-19304958D1E3}"/>
               </a:ext>
             </a:extLst>
           </p:cNvPr>
@@ -7259,8 +7259,8 @@
         </p:blipFill>
         <p:spPr>
           <a:xfrm>
-            <a:off x="1724024" y="719138"/>
-            <a:ext cx="5695950" cy="3848100"/>
+            <a:off x="1719261" y="685800"/>
+            <a:ext cx="5705475" cy="3914775"/>
           </a:xfrm>
           <a:prstGeom prst="rect">
             <a:avLst/>

</xml_diff>